<commit_message>
small edits to SOM figs
</commit_message>
<xml_diff>
--- a/figs/experimental_design_space.pptx
+++ b/figs/experimental_design_space.pptx
@@ -118,6 +118,7 @@
 <file path=ppt/revisionInfo.xml><?xml version="1.0" encoding="utf-8"?>
 <p1510:revInfo xmlns:a="http://schemas.openxmlformats.org/drawingml/2006/main" xmlns:r="http://schemas.openxmlformats.org/officeDocument/2006/relationships" xmlns:p1510="http://schemas.microsoft.com/office/powerpoint/2015/10/main">
   <p1510:revLst>
+    <p1510:client id="{28444902-C997-435E-B04E-23A620ED9E6D}" v="1" dt="2026-07-09T00:16:40.777"/>
     <p1510:client id="{BC0D4B74-02B6-4A54-81EE-85EBA6C46217}" v="76" dt="2026-07-08T21:57:03.114"/>
   </p1510:revLst>
 </p1510:revInfo>
@@ -128,12 +129,12 @@
   <pc:docChgLst>
     <pc:chgData name="Zachary Randell" userId="4632875424_tp_dropbox_plus" providerId="OAuth2" clId="{94F170DD-8542-47A7-905C-5CC9F103855A}"/>
     <pc:docChg chg="undo custSel delSld modSld">
-      <pc:chgData name="Zachary Randell" userId="4632875424_tp_dropbox_plus" providerId="OAuth2" clId="{94F170DD-8542-47A7-905C-5CC9F103855A}" dt="2026-07-08T21:58:08.574" v="414" actId="1076"/>
+      <pc:chgData name="Zachary Randell" userId="4632875424_tp_dropbox_plus" providerId="OAuth2" clId="{94F170DD-8542-47A7-905C-5CC9F103855A}" dt="2026-07-09T00:18:34.870" v="587" actId="1076"/>
       <pc:docMkLst>
         <pc:docMk/>
       </pc:docMkLst>
       <pc:sldChg chg="addSp delSp modSp mod">
-        <pc:chgData name="Zachary Randell" userId="4632875424_tp_dropbox_plus" providerId="OAuth2" clId="{94F170DD-8542-47A7-905C-5CC9F103855A}" dt="2026-07-08T21:58:08.574" v="414" actId="1076"/>
+        <pc:chgData name="Zachary Randell" userId="4632875424_tp_dropbox_plus" providerId="OAuth2" clId="{94F170DD-8542-47A7-905C-5CC9F103855A}" dt="2026-07-09T00:18:34.870" v="587" actId="1076"/>
         <pc:sldMkLst>
           <pc:docMk/>
           <pc:sldMk cId="1105578165" sldId="256"/>
@@ -210,12 +211,20 @@
             <ac:spMk id="35" creationId="{AC6A3E22-4672-805D-5D98-B54A5E709FCE}"/>
           </ac:spMkLst>
         </pc:spChg>
-        <pc:spChg chg="mod">
-          <ac:chgData name="Zachary Randell" userId="4632875424_tp_dropbox_plus" providerId="OAuth2" clId="{94F170DD-8542-47A7-905C-5CC9F103855A}" dt="2026-07-06T15:27:23.882" v="15" actId="14100"/>
+        <pc:spChg chg="mod topLvl">
+          <ac:chgData name="Zachary Randell" userId="4632875424_tp_dropbox_plus" providerId="OAuth2" clId="{94F170DD-8542-47A7-905C-5CC9F103855A}" dt="2026-07-09T00:17:22.678" v="426" actId="1076"/>
           <ac:spMkLst>
             <pc:docMk/>
             <pc:sldMk cId="1105578165" sldId="256"/>
             <ac:spMk id="42" creationId="{82D3663F-7B6A-2015-678E-F03884579831}"/>
+          </ac:spMkLst>
+        </pc:spChg>
+        <pc:spChg chg="mod topLvl">
+          <ac:chgData name="Zachary Randell" userId="4632875424_tp_dropbox_plus" providerId="OAuth2" clId="{94F170DD-8542-47A7-905C-5CC9F103855A}" dt="2026-07-09T00:17:03.540" v="424" actId="14100"/>
+          <ac:spMkLst>
+            <pc:docMk/>
+            <pc:sldMk cId="1105578165" sldId="256"/>
+            <ac:spMk id="43" creationId="{D6CAE37E-87E3-749B-33EC-D9654C67A6A8}"/>
           </ac:spMkLst>
         </pc:spChg>
         <pc:spChg chg="add mod">
@@ -283,7 +292,7 @@
           </ac:spMkLst>
         </pc:spChg>
         <pc:spChg chg="mod">
-          <ac:chgData name="Zachary Randell" userId="4632875424_tp_dropbox_plus" providerId="OAuth2" clId="{94F170DD-8542-47A7-905C-5CC9F103855A}" dt="2026-07-08T21:57:45.273" v="411" actId="1076"/>
+          <ac:chgData name="Zachary Randell" userId="4632875424_tp_dropbox_plus" providerId="OAuth2" clId="{94F170DD-8542-47A7-905C-5CC9F103855A}" dt="2026-07-09T00:18:34.870" v="587" actId="1076"/>
           <ac:spMkLst>
             <pc:docMk/>
             <pc:sldMk cId="1105578165" sldId="256"/>
@@ -306,8 +315,8 @@
             <ac:spMk id="280" creationId="{D527790C-BE39-E6A0-D2F8-49AA06A2E491}"/>
           </ac:spMkLst>
         </pc:spChg>
-        <pc:grpChg chg="mod">
-          <ac:chgData name="Zachary Randell" userId="4632875424_tp_dropbox_plus" providerId="OAuth2" clId="{94F170DD-8542-47A7-905C-5CC9F103855A}" dt="2026-07-06T15:27:27.616" v="16" actId="14100"/>
+        <pc:grpChg chg="del mod">
+          <ac:chgData name="Zachary Randell" userId="4632875424_tp_dropbox_plus" providerId="OAuth2" clId="{94F170DD-8542-47A7-905C-5CC9F103855A}" dt="2026-07-09T00:16:40.777" v="420" actId="165"/>
           <ac:grpSpMkLst>
             <pc:docMk/>
             <pc:sldMk cId="1105578165" sldId="256"/>
@@ -1985,7 +1994,7 @@
           <a:p>
             <a:fld id="{D8F5B7E5-F99F-471B-B3DE-57965D1045F7}" type="datetimeFigureOut">
               <a:rPr lang="en-US" smtClean="0"/>
-              <a:t>7/6/2026</a:t>
+              <a:t>7/8/2026</a:t>
             </a:fld>
             <a:endParaRPr lang="en-US"/>
           </a:p>
@@ -2383,7 +2392,7 @@
           <a:p>
             <a:fld id="{69B944B8-7A9A-4030-BC91-8FDE173981C2}" type="datetimeFigureOut">
               <a:rPr lang="en-US" smtClean="0"/>
-              <a:t>7/6/2026</a:t>
+              <a:t>7/8/2026</a:t>
             </a:fld>
             <a:endParaRPr lang="en-US"/>
           </a:p>
@@ -2553,7 +2562,7 @@
           <a:p>
             <a:fld id="{69B944B8-7A9A-4030-BC91-8FDE173981C2}" type="datetimeFigureOut">
               <a:rPr lang="en-US" smtClean="0"/>
-              <a:t>7/6/2026</a:t>
+              <a:t>7/8/2026</a:t>
             </a:fld>
             <a:endParaRPr lang="en-US"/>
           </a:p>
@@ -2733,7 +2742,7 @@
           <a:p>
             <a:fld id="{69B944B8-7A9A-4030-BC91-8FDE173981C2}" type="datetimeFigureOut">
               <a:rPr lang="en-US" smtClean="0"/>
-              <a:t>7/6/2026</a:t>
+              <a:t>7/8/2026</a:t>
             </a:fld>
             <a:endParaRPr lang="en-US"/>
           </a:p>
@@ -2903,7 +2912,7 @@
           <a:p>
             <a:fld id="{69B944B8-7A9A-4030-BC91-8FDE173981C2}" type="datetimeFigureOut">
               <a:rPr lang="en-US" smtClean="0"/>
-              <a:t>7/6/2026</a:t>
+              <a:t>7/8/2026</a:t>
             </a:fld>
             <a:endParaRPr lang="en-US"/>
           </a:p>
@@ -3149,7 +3158,7 @@
           <a:p>
             <a:fld id="{69B944B8-7A9A-4030-BC91-8FDE173981C2}" type="datetimeFigureOut">
               <a:rPr lang="en-US" smtClean="0"/>
-              <a:t>7/6/2026</a:t>
+              <a:t>7/8/2026</a:t>
             </a:fld>
             <a:endParaRPr lang="en-US"/>
           </a:p>
@@ -3381,7 +3390,7 @@
           <a:p>
             <a:fld id="{69B944B8-7A9A-4030-BC91-8FDE173981C2}" type="datetimeFigureOut">
               <a:rPr lang="en-US" smtClean="0"/>
-              <a:t>7/6/2026</a:t>
+              <a:t>7/8/2026</a:t>
             </a:fld>
             <a:endParaRPr lang="en-US"/>
           </a:p>
@@ -3748,7 +3757,7 @@
           <a:p>
             <a:fld id="{69B944B8-7A9A-4030-BC91-8FDE173981C2}" type="datetimeFigureOut">
               <a:rPr lang="en-US" smtClean="0"/>
-              <a:t>7/6/2026</a:t>
+              <a:t>7/8/2026</a:t>
             </a:fld>
             <a:endParaRPr lang="en-US"/>
           </a:p>
@@ -3866,7 +3875,7 @@
           <a:p>
             <a:fld id="{69B944B8-7A9A-4030-BC91-8FDE173981C2}" type="datetimeFigureOut">
               <a:rPr lang="en-US" smtClean="0"/>
-              <a:t>7/6/2026</a:t>
+              <a:t>7/8/2026</a:t>
             </a:fld>
             <a:endParaRPr lang="en-US"/>
           </a:p>
@@ -3961,7 +3970,7 @@
           <a:p>
             <a:fld id="{69B944B8-7A9A-4030-BC91-8FDE173981C2}" type="datetimeFigureOut">
               <a:rPr lang="en-US" smtClean="0"/>
-              <a:t>7/6/2026</a:t>
+              <a:t>7/8/2026</a:t>
             </a:fld>
             <a:endParaRPr lang="en-US"/>
           </a:p>
@@ -4238,7 +4247,7 @@
           <a:p>
             <a:fld id="{69B944B8-7A9A-4030-BC91-8FDE173981C2}" type="datetimeFigureOut">
               <a:rPr lang="en-US" smtClean="0"/>
-              <a:t>7/6/2026</a:t>
+              <a:t>7/8/2026</a:t>
             </a:fld>
             <a:endParaRPr lang="en-US"/>
           </a:p>
@@ -4495,7 +4504,7 @@
           <a:p>
             <a:fld id="{69B944B8-7A9A-4030-BC91-8FDE173981C2}" type="datetimeFigureOut">
               <a:rPr lang="en-US" smtClean="0"/>
-              <a:t>7/6/2026</a:t>
+              <a:t>7/8/2026</a:t>
             </a:fld>
             <a:endParaRPr lang="en-US"/>
           </a:p>
@@ -4708,7 +4717,7 @@
           <a:p>
             <a:fld id="{69B944B8-7A9A-4030-BC91-8FDE173981C2}" type="datetimeFigureOut">
               <a:rPr lang="en-US" smtClean="0"/>
-              <a:t>7/6/2026</a:t>
+              <a:t>7/8/2026</a:t>
             </a:fld>
             <a:endParaRPr lang="en-US"/>
           </a:p>
@@ -6073,143 +6082,122 @@
           </a:p>
         </p:txBody>
       </p:sp>
-      <p:grpSp>
-        <p:nvGrpSpPr>
-          <p:cNvPr id="41" name="Group 40">
+      <p:sp>
+        <p:nvSpPr>
+          <p:cNvPr id="43" name="Rectangle 42">
             <a:extLst>
               <a:ext uri="{FF2B5EF4-FFF2-40B4-BE49-F238E27FC236}">
-                <a16:creationId xmlns:a16="http://schemas.microsoft.com/office/drawing/2014/main" id="{DF6A1024-A228-BD60-B89C-C42FF4A42B24}"/>
+                <a16:creationId xmlns:a16="http://schemas.microsoft.com/office/drawing/2014/main" id="{D6CAE37E-87E3-749B-33EC-D9654C67A6A8}"/>
               </a:ext>
             </a:extLst>
           </p:cNvPr>
-          <p:cNvGrpSpPr/>
+          <p:cNvSpPr/>
           <p:nvPr/>
-        </p:nvGrpSpPr>
-        <p:grpSpPr>
+        </p:nvSpPr>
+        <p:spPr>
           <a:xfrm>
-            <a:off x="6202816" y="5066023"/>
-            <a:ext cx="619125" cy="581025"/>
-            <a:chOff x="7155321" y="6067887"/>
-            <a:chExt cx="619125" cy="581025"/>
+            <a:off x="6202816" y="5351523"/>
+            <a:ext cx="619125" cy="295523"/>
           </a:xfrm>
-        </p:grpSpPr>
-        <p:sp>
-          <p:nvSpPr>
-            <p:cNvPr id="43" name="Rectangle 42">
-              <a:extLst>
-                <a:ext uri="{FF2B5EF4-FFF2-40B4-BE49-F238E27FC236}">
-                  <a16:creationId xmlns:a16="http://schemas.microsoft.com/office/drawing/2014/main" id="{D6CAE37E-87E3-749B-33EC-D9654C67A6A8}"/>
-                </a:ext>
-              </a:extLst>
-            </p:cNvPr>
-            <p:cNvSpPr/>
-            <p:nvPr/>
-          </p:nvSpPr>
-          <p:spPr>
-            <a:xfrm>
-              <a:off x="7155321" y="6178653"/>
-              <a:ext cx="619125" cy="470259"/>
-            </a:xfrm>
-            <a:prstGeom prst="rect">
-              <a:avLst/>
-            </a:prstGeom>
-            <a:solidFill>
-              <a:srgbClr val="198FA3"/>
-            </a:solidFill>
-            <a:ln>
-              <a:noFill/>
-            </a:ln>
-          </p:spPr>
-          <p:style>
-            <a:lnRef idx="2">
-              <a:schemeClr val="accent1">
-                <a:shade val="50000"/>
-              </a:schemeClr>
-            </a:lnRef>
-            <a:fillRef idx="1">
-              <a:schemeClr val="accent1"/>
-            </a:fillRef>
-            <a:effectRef idx="0">
-              <a:schemeClr val="accent1"/>
-            </a:effectRef>
-            <a:fontRef idx="minor">
-              <a:schemeClr val="lt1"/>
-            </a:fontRef>
-          </p:style>
-          <p:txBody>
-            <a:bodyPr rtlCol="0" anchor="ctr"/>
-            <a:lstStyle/>
-            <a:p>
-              <a:pPr algn="ctr"/>
-              <a:endParaRPr lang="en-US">
-                <a:solidFill>
-                  <a:schemeClr val="tx1"/>
-                </a:solidFill>
-              </a:endParaRPr>
-            </a:p>
-          </p:txBody>
-        </p:sp>
-        <p:sp>
-          <p:nvSpPr>
-            <p:cNvPr id="42" name="Rectangle 41">
-              <a:extLst>
-                <a:ext uri="{FF2B5EF4-FFF2-40B4-BE49-F238E27FC236}">
-                  <a16:creationId xmlns:a16="http://schemas.microsoft.com/office/drawing/2014/main" id="{82D3663F-7B6A-2015-678E-F03884579831}"/>
-                </a:ext>
-              </a:extLst>
-            </p:cNvPr>
-            <p:cNvSpPr/>
-            <p:nvPr/>
-          </p:nvSpPr>
-          <p:spPr>
-            <a:xfrm>
-              <a:off x="7155321" y="6067887"/>
-              <a:ext cx="619125" cy="581025"/>
-            </a:xfrm>
-            <a:prstGeom prst="rect">
-              <a:avLst/>
-            </a:prstGeom>
-            <a:solidFill>
-              <a:schemeClr val="bg1">
-                <a:alpha val="0"/>
-              </a:schemeClr>
-            </a:solidFill>
-            <a:ln>
+          <a:prstGeom prst="rect">
+            <a:avLst/>
+          </a:prstGeom>
+          <a:solidFill>
+            <a:srgbClr val="198FA3"/>
+          </a:solidFill>
+          <a:ln>
+            <a:noFill/>
+          </a:ln>
+        </p:spPr>
+        <p:style>
+          <a:lnRef idx="2">
+            <a:schemeClr val="accent1">
+              <a:shade val="50000"/>
+            </a:schemeClr>
+          </a:lnRef>
+          <a:fillRef idx="1">
+            <a:schemeClr val="accent1"/>
+          </a:fillRef>
+          <a:effectRef idx="0">
+            <a:schemeClr val="accent1"/>
+          </a:effectRef>
+          <a:fontRef idx="minor">
+            <a:schemeClr val="lt1"/>
+          </a:fontRef>
+        </p:style>
+        <p:txBody>
+          <a:bodyPr rtlCol="0" anchor="ctr"/>
+          <a:lstStyle/>
+          <a:p>
+            <a:pPr algn="ctr"/>
+            <a:endParaRPr lang="en-US">
               <a:solidFill>
                 <a:schemeClr val="tx1"/>
               </a:solidFill>
-            </a:ln>
-          </p:spPr>
-          <p:style>
-            <a:lnRef idx="2">
-              <a:schemeClr val="accent1">
-                <a:shade val="50000"/>
-              </a:schemeClr>
-            </a:lnRef>
-            <a:fillRef idx="1">
-              <a:schemeClr val="accent1"/>
-            </a:fillRef>
-            <a:effectRef idx="0">
-              <a:schemeClr val="accent1"/>
-            </a:effectRef>
-            <a:fontRef idx="minor">
-              <a:schemeClr val="lt1"/>
-            </a:fontRef>
-          </p:style>
-          <p:txBody>
-            <a:bodyPr rtlCol="0" anchor="ctr"/>
-            <a:lstStyle/>
-            <a:p>
-              <a:pPr algn="ctr"/>
-              <a:endParaRPr lang="en-US">
-                <a:solidFill>
-                  <a:schemeClr val="tx1"/>
-                </a:solidFill>
-              </a:endParaRPr>
-            </a:p>
-          </p:txBody>
-        </p:sp>
-      </p:grpSp>
+            </a:endParaRPr>
+          </a:p>
+        </p:txBody>
+      </p:sp>
+      <p:sp>
+        <p:nvSpPr>
+          <p:cNvPr id="42" name="Rectangle 41">
+            <a:extLst>
+              <a:ext uri="{FF2B5EF4-FFF2-40B4-BE49-F238E27FC236}">
+                <a16:creationId xmlns:a16="http://schemas.microsoft.com/office/drawing/2014/main" id="{82D3663F-7B6A-2015-678E-F03884579831}"/>
+              </a:ext>
+            </a:extLst>
+          </p:cNvPr>
+          <p:cNvSpPr/>
+          <p:nvPr/>
+        </p:nvSpPr>
+        <p:spPr>
+          <a:xfrm>
+            <a:off x="6209777" y="5066023"/>
+            <a:ext cx="619125" cy="581025"/>
+          </a:xfrm>
+          <a:prstGeom prst="rect">
+            <a:avLst/>
+          </a:prstGeom>
+          <a:solidFill>
+            <a:schemeClr val="bg1">
+              <a:alpha val="0"/>
+            </a:schemeClr>
+          </a:solidFill>
+          <a:ln>
+            <a:solidFill>
+              <a:schemeClr val="tx1"/>
+            </a:solidFill>
+          </a:ln>
+        </p:spPr>
+        <p:style>
+          <a:lnRef idx="2">
+            <a:schemeClr val="accent1">
+              <a:shade val="50000"/>
+            </a:schemeClr>
+          </a:lnRef>
+          <a:fillRef idx="1">
+            <a:schemeClr val="accent1"/>
+          </a:fillRef>
+          <a:effectRef idx="0">
+            <a:schemeClr val="accent1"/>
+          </a:effectRef>
+          <a:fontRef idx="minor">
+            <a:schemeClr val="lt1"/>
+          </a:fontRef>
+        </p:style>
+        <p:txBody>
+          <a:bodyPr rtlCol="0" anchor="ctr"/>
+          <a:lstStyle/>
+          <a:p>
+            <a:pPr algn="ctr"/>
+            <a:endParaRPr lang="en-US" dirty="0">
+              <a:solidFill>
+                <a:schemeClr val="tx1"/>
+              </a:solidFill>
+            </a:endParaRPr>
+          </a:p>
+        </p:txBody>
+      </p:sp>
       <p:sp>
         <p:nvSpPr>
           <p:cNvPr id="54" name="TextBox 53">
@@ -8704,7 +8692,7 @@
         </p:nvSpPr>
         <p:spPr>
           <a:xfrm>
-            <a:off x="7576652" y="4996207"/>
+            <a:off x="7519723" y="5005444"/>
             <a:ext cx="3511095" cy="1046440"/>
           </a:xfrm>
           <a:prstGeom prst="rect">
@@ -8732,7 +8720,7 @@
                 <a:latin typeface="+mj-lt"/>
                 <a:ea typeface="Gadugi" panose="020B0502040204020203" pitchFamily="34" charset="0"/>
               </a:rPr>
-              <a:t>n=20 1 x 1 x 0.4m cages</a:t>
+              <a:t>n=20 1 x 1 x 0.4m cages; not to scale.</a:t>
             </a:r>
           </a:p>
           <a:p>
@@ -8741,7 +8729,7 @@
                 <a:latin typeface="+mj-lt"/>
                 <a:ea typeface="Gadugi" panose="020B0502040204020203" pitchFamily="34" charset="0"/>
               </a:rPr>
-              <a:t>Not to scale; one “urchin control” cage not shown or analyzed</a:t>
+              <a:t>One “urchin control” cage not shown or retained for this manuscript’s analyses</a:t>
             </a:r>
           </a:p>
         </p:txBody>

</xml_diff>